<commit_message>
Updated slides, as I missed one out
</commit_message>
<xml_diff>
--- a/Low Cost Low Stress Approaches to Open Source tools.pptx
+++ b/Low Cost Low Stress Approaches to Open Source tools.pptx
@@ -5,7 +5,7 @@
     <p:sldMasterId id="2147483648" r:id="rId4"/>
   </p:sldMasterIdLst>
   <p:notesMasterIdLst>
-    <p:notesMasterId r:id="rId22"/>
+    <p:notesMasterId r:id="rId23"/>
   </p:notesMasterIdLst>
   <p:sldIdLst>
     <p:sldId id="256" r:id="rId5"/>
@@ -16,15 +16,16 @@
     <p:sldId id="268" r:id="rId10"/>
     <p:sldId id="289" r:id="rId11"/>
     <p:sldId id="300" r:id="rId12"/>
-    <p:sldId id="302" r:id="rId13"/>
-    <p:sldId id="303" r:id="rId14"/>
-    <p:sldId id="301" r:id="rId15"/>
-    <p:sldId id="306" r:id="rId16"/>
-    <p:sldId id="307" r:id="rId17"/>
-    <p:sldId id="304" r:id="rId18"/>
-    <p:sldId id="305" r:id="rId19"/>
-    <p:sldId id="267" r:id="rId20"/>
-    <p:sldId id="309" r:id="rId21"/>
+    <p:sldId id="311" r:id="rId13"/>
+    <p:sldId id="310" r:id="rId14"/>
+    <p:sldId id="303" r:id="rId15"/>
+    <p:sldId id="301" r:id="rId16"/>
+    <p:sldId id="306" r:id="rId17"/>
+    <p:sldId id="307" r:id="rId18"/>
+    <p:sldId id="304" r:id="rId19"/>
+    <p:sldId id="305" r:id="rId20"/>
+    <p:sldId id="267" r:id="rId21"/>
+    <p:sldId id="309" r:id="rId22"/>
   </p:sldIdLst>
   <p:sldSz cx="12192000" cy="6858000"/>
   <p:notesSz cx="6858000" cy="9144000"/>
@@ -136,9 +137,10 @@
 <p1510:revInfo xmlns:a="http://schemas.openxmlformats.org/drawingml/2006/main" xmlns:r="http://schemas.openxmlformats.org/officeDocument/2006/relationships" xmlns:p1510="http://schemas.microsoft.com/office/powerpoint/2015/10/main">
   <p1510:revLst>
     <p1510:client id="{36E081B6-492A-88C0-B5FA-77C245F7BF56}" v="3" dt="2026-05-05T22:10:05.537"/>
-    <p1510:client id="{469B5051-5EC7-9E47-8DDC-649609147315}" v="47" dt="2026-05-05T21:42:10.601"/>
+    <p1510:client id="{469B5051-5EC7-9E47-8DDC-649609147315}" v="51" dt="2026-05-05T23:01:46.030"/>
     <p1510:client id="{4F59D42D-8097-499F-9F8D-CCF2A2027F94}" v="295" dt="2026-05-05T02:39:51.225"/>
     <p1510:client id="{5A8A33D3-215F-8A95-79C7-55071864AF8B}" v="63" dt="2026-05-05T02:01:56.717"/>
+    <p1510:client id="{EDE0496E-E3D2-885E-396E-EB539D8668C1}" v="65" dt="2026-05-05T22:56:10.325"/>
   </p1510:revLst>
 </p1510:revInfo>
 </file>
@@ -1005,212 +1007,6 @@
     </pc:docChg>
   </pc:docChgLst>
   <pc:docChgLst>
-    <pc:chgData name="Shanna Tervoort-McLeod" userId="253d0e36-d0bf-47b4-b4e5-27c32d8025c0" providerId="ADAL" clId="{292B3924-7E15-5699-88F2-F017F785F965}"/>
-    <pc:docChg chg="custSel modSld">
-      <pc:chgData name="Shanna Tervoort-McLeod" userId="253d0e36-d0bf-47b4-b4e5-27c32d8025c0" providerId="ADAL" clId="{292B3924-7E15-5699-88F2-F017F785F965}" dt="2026-05-05T21:45:01.763" v="56" actId="1076"/>
-      <pc:docMkLst>
-        <pc:docMk/>
-      </pc:docMkLst>
-      <pc:sldChg chg="modSp mod">
-        <pc:chgData name="Shanna Tervoort-McLeod" userId="253d0e36-d0bf-47b4-b4e5-27c32d8025c0" providerId="ADAL" clId="{292B3924-7E15-5699-88F2-F017F785F965}" dt="2026-05-05T21:29:37.277" v="0" actId="113"/>
-        <pc:sldMkLst>
-          <pc:docMk/>
-          <pc:sldMk cId="3812533663" sldId="256"/>
-        </pc:sldMkLst>
-        <pc:spChg chg="mod">
-          <ac:chgData name="Shanna Tervoort-McLeod" userId="253d0e36-d0bf-47b4-b4e5-27c32d8025c0" providerId="ADAL" clId="{292B3924-7E15-5699-88F2-F017F785F965}" dt="2026-05-05T21:29:37.277" v="0" actId="113"/>
-          <ac:spMkLst>
-            <pc:docMk/>
-            <pc:sldMk cId="3812533663" sldId="256"/>
-            <ac:spMk id="2" creationId="{A46922D6-CA7A-4822-2C87-11A521B48D6C}"/>
-          </ac:spMkLst>
-        </pc:spChg>
-      </pc:sldChg>
-      <pc:sldChg chg="modSp mod">
-        <pc:chgData name="Shanna Tervoort-McLeod" userId="253d0e36-d0bf-47b4-b4e5-27c32d8025c0" providerId="ADAL" clId="{292B3924-7E15-5699-88F2-F017F785F965}" dt="2026-05-05T21:36:03.282" v="23" actId="20577"/>
-        <pc:sldMkLst>
-          <pc:docMk/>
-          <pc:sldMk cId="2723548160" sldId="289"/>
-        </pc:sldMkLst>
-        <pc:spChg chg="mod">
-          <ac:chgData name="Shanna Tervoort-McLeod" userId="253d0e36-d0bf-47b4-b4e5-27c32d8025c0" providerId="ADAL" clId="{292B3924-7E15-5699-88F2-F017F785F965}" dt="2026-05-05T21:36:03.282" v="23" actId="20577"/>
-          <ac:spMkLst>
-            <pc:docMk/>
-            <pc:sldMk cId="2723548160" sldId="289"/>
-            <ac:spMk id="3" creationId="{C42A2B45-25C9-E5C9-F733-3580062FC60A}"/>
-          </ac:spMkLst>
-        </pc:spChg>
-      </pc:sldChg>
-      <pc:sldChg chg="modSp mod">
-        <pc:chgData name="Shanna Tervoort-McLeod" userId="253d0e36-d0bf-47b4-b4e5-27c32d8025c0" providerId="ADAL" clId="{292B3924-7E15-5699-88F2-F017F785F965}" dt="2026-05-05T21:31:11.347" v="1" actId="12"/>
-        <pc:sldMkLst>
-          <pc:docMk/>
-          <pc:sldMk cId="1627143753" sldId="296"/>
-        </pc:sldMkLst>
-        <pc:spChg chg="mod">
-          <ac:chgData name="Shanna Tervoort-McLeod" userId="253d0e36-d0bf-47b4-b4e5-27c32d8025c0" providerId="ADAL" clId="{292B3924-7E15-5699-88F2-F017F785F965}" dt="2026-05-05T21:31:11.347" v="1" actId="12"/>
-          <ac:spMkLst>
-            <pc:docMk/>
-            <pc:sldMk cId="1627143753" sldId="296"/>
-            <ac:spMk id="4" creationId="{7A399886-A7EF-3AFB-834D-E3144844208E}"/>
-          </ac:spMkLst>
-        </pc:spChg>
-      </pc:sldChg>
-      <pc:sldChg chg="addSp modSp mod">
-        <pc:chgData name="Shanna Tervoort-McLeod" userId="253d0e36-d0bf-47b4-b4e5-27c32d8025c0" providerId="ADAL" clId="{292B3924-7E15-5699-88F2-F017F785F965}" dt="2026-05-05T21:37:47.120" v="37" actId="1076"/>
-        <pc:sldMkLst>
-          <pc:docMk/>
-          <pc:sldMk cId="338454694" sldId="299"/>
-        </pc:sldMkLst>
-        <pc:spChg chg="mod">
-          <ac:chgData name="Shanna Tervoort-McLeod" userId="253d0e36-d0bf-47b4-b4e5-27c32d8025c0" providerId="ADAL" clId="{292B3924-7E15-5699-88F2-F017F785F965}" dt="2026-05-05T21:35:47.573" v="20" actId="14100"/>
-          <ac:spMkLst>
-            <pc:docMk/>
-            <pc:sldMk cId="338454694" sldId="299"/>
-            <ac:spMk id="4" creationId="{23025534-4FEA-689C-77C7-F44F76ACC956}"/>
-          </ac:spMkLst>
-        </pc:spChg>
-        <pc:picChg chg="add mod">
-          <ac:chgData name="Shanna Tervoort-McLeod" userId="253d0e36-d0bf-47b4-b4e5-27c32d8025c0" providerId="ADAL" clId="{292B3924-7E15-5699-88F2-F017F785F965}" dt="2026-05-05T21:37:47.120" v="37" actId="1076"/>
-          <ac:picMkLst>
-            <pc:docMk/>
-            <pc:sldMk cId="338454694" sldId="299"/>
-            <ac:picMk id="5" creationId="{FB710EE5-6207-B7A4-36EB-CA0F609EE198}"/>
-          </ac:picMkLst>
-        </pc:picChg>
-      </pc:sldChg>
-      <pc:sldChg chg="addSp modSp mod">
-        <pc:chgData name="Shanna Tervoort-McLeod" userId="253d0e36-d0bf-47b4-b4e5-27c32d8025c0" providerId="ADAL" clId="{292B3924-7E15-5699-88F2-F017F785F965}" dt="2026-05-05T21:45:01.763" v="56" actId="1076"/>
-        <pc:sldMkLst>
-          <pc:docMk/>
-          <pc:sldMk cId="491669475" sldId="301"/>
-        </pc:sldMkLst>
-        <pc:spChg chg="mod">
-          <ac:chgData name="Shanna Tervoort-McLeod" userId="253d0e36-d0bf-47b4-b4e5-27c32d8025c0" providerId="ADAL" clId="{292B3924-7E15-5699-88F2-F017F785F965}" dt="2026-05-05T21:36:35.621" v="28" actId="14100"/>
-          <ac:spMkLst>
-            <pc:docMk/>
-            <pc:sldMk cId="491669475" sldId="301"/>
-            <ac:spMk id="3" creationId="{0BD444BF-6F55-619A-1EE5-FD3B9DC0B403}"/>
-          </ac:spMkLst>
-        </pc:spChg>
-        <pc:picChg chg="add mod">
-          <ac:chgData name="Shanna Tervoort-McLeod" userId="253d0e36-d0bf-47b4-b4e5-27c32d8025c0" providerId="ADAL" clId="{292B3924-7E15-5699-88F2-F017F785F965}" dt="2026-05-05T21:45:01.763" v="56" actId="1076"/>
-          <ac:picMkLst>
-            <pc:docMk/>
-            <pc:sldMk cId="491669475" sldId="301"/>
-            <ac:picMk id="4" creationId="{65A64BC6-2670-5588-CD05-270E75A70649}"/>
-          </ac:picMkLst>
-        </pc:picChg>
-      </pc:sldChg>
-      <pc:sldChg chg="modSp mod">
-        <pc:chgData name="Shanna Tervoort-McLeod" userId="253d0e36-d0bf-47b4-b4e5-27c32d8025c0" providerId="ADAL" clId="{292B3924-7E15-5699-88F2-F017F785F965}" dt="2026-05-05T21:32:43.650" v="10" actId="20577"/>
-        <pc:sldMkLst>
-          <pc:docMk/>
-          <pc:sldMk cId="2369738800" sldId="302"/>
-        </pc:sldMkLst>
-        <pc:spChg chg="mod">
-          <ac:chgData name="Shanna Tervoort-McLeod" userId="253d0e36-d0bf-47b4-b4e5-27c32d8025c0" providerId="ADAL" clId="{292B3924-7E15-5699-88F2-F017F785F965}" dt="2026-05-05T21:32:43.650" v="10" actId="20577"/>
-          <ac:spMkLst>
-            <pc:docMk/>
-            <pc:sldMk cId="2369738800" sldId="302"/>
-            <ac:spMk id="2" creationId="{C011AEAB-AA53-5478-E484-A35881BD8E2A}"/>
-          </ac:spMkLst>
-        </pc:spChg>
-      </pc:sldChg>
-      <pc:sldChg chg="modSp mod">
-        <pc:chgData name="Shanna Tervoort-McLeod" userId="253d0e36-d0bf-47b4-b4e5-27c32d8025c0" providerId="ADAL" clId="{292B3924-7E15-5699-88F2-F017F785F965}" dt="2026-05-05T21:32:56.022" v="12" actId="20577"/>
-        <pc:sldMkLst>
-          <pc:docMk/>
-          <pc:sldMk cId="2103267894" sldId="303"/>
-        </pc:sldMkLst>
-        <pc:spChg chg="mod">
-          <ac:chgData name="Shanna Tervoort-McLeod" userId="253d0e36-d0bf-47b4-b4e5-27c32d8025c0" providerId="ADAL" clId="{292B3924-7E15-5699-88F2-F017F785F965}" dt="2026-05-05T21:32:56.022" v="12" actId="20577"/>
-          <ac:spMkLst>
-            <pc:docMk/>
-            <pc:sldMk cId="2103267894" sldId="303"/>
-            <ac:spMk id="2" creationId="{AD2C492B-184C-0B13-B356-4A1ED7940BC5}"/>
-          </ac:spMkLst>
-        </pc:spChg>
-      </pc:sldChg>
-      <pc:sldChg chg="addSp modSp mod">
-        <pc:chgData name="Shanna Tervoort-McLeod" userId="253d0e36-d0bf-47b4-b4e5-27c32d8025c0" providerId="ADAL" clId="{292B3924-7E15-5699-88F2-F017F785F965}" dt="2026-05-05T21:42:10.601" v="49" actId="1076"/>
-        <pc:sldMkLst>
-          <pc:docMk/>
-          <pc:sldMk cId="2215040014" sldId="305"/>
-        </pc:sldMkLst>
-        <pc:spChg chg="mod">
-          <ac:chgData name="Shanna Tervoort-McLeod" userId="253d0e36-d0bf-47b4-b4e5-27c32d8025c0" providerId="ADAL" clId="{292B3924-7E15-5699-88F2-F017F785F965}" dt="2026-05-05T21:40:42.651" v="39" actId="27636"/>
-          <ac:spMkLst>
-            <pc:docMk/>
-            <pc:sldMk cId="2215040014" sldId="305"/>
-            <ac:spMk id="3" creationId="{38B7C271-EA34-8727-38AB-6A855D64399D}"/>
-          </ac:spMkLst>
-        </pc:spChg>
-        <pc:picChg chg="add mod">
-          <ac:chgData name="Shanna Tervoort-McLeod" userId="253d0e36-d0bf-47b4-b4e5-27c32d8025c0" providerId="ADAL" clId="{292B3924-7E15-5699-88F2-F017F785F965}" dt="2026-05-05T21:42:10.601" v="49" actId="1076"/>
-          <ac:picMkLst>
-            <pc:docMk/>
-            <pc:sldMk cId="2215040014" sldId="305"/>
-            <ac:picMk id="4" creationId="{A0FD42A8-CD31-47B8-B0D6-CD485E3F2824}"/>
-          </ac:picMkLst>
-        </pc:picChg>
-        <pc:picChg chg="add mod">
-          <ac:chgData name="Shanna Tervoort-McLeod" userId="253d0e36-d0bf-47b4-b4e5-27c32d8025c0" providerId="ADAL" clId="{292B3924-7E15-5699-88F2-F017F785F965}" dt="2026-05-05T21:42:10.601" v="49" actId="1076"/>
-          <ac:picMkLst>
-            <pc:docMk/>
-            <pc:sldMk cId="2215040014" sldId="305"/>
-            <ac:picMk id="5" creationId="{E2146A93-A7CD-7000-66B4-4C5BE939DA6E}"/>
-          </ac:picMkLst>
-        </pc:picChg>
-      </pc:sldChg>
-      <pc:sldChg chg="modSp mod">
-        <pc:chgData name="Shanna Tervoort-McLeod" userId="253d0e36-d0bf-47b4-b4e5-27c32d8025c0" providerId="ADAL" clId="{292B3924-7E15-5699-88F2-F017F785F965}" dt="2026-05-05T21:33:34.212" v="14" actId="20577"/>
-        <pc:sldMkLst>
-          <pc:docMk/>
-          <pc:sldMk cId="936306167" sldId="306"/>
-        </pc:sldMkLst>
-        <pc:spChg chg="mod">
-          <ac:chgData name="Shanna Tervoort-McLeod" userId="253d0e36-d0bf-47b4-b4e5-27c32d8025c0" providerId="ADAL" clId="{292B3924-7E15-5699-88F2-F017F785F965}" dt="2026-05-05T21:33:34.212" v="14" actId="20577"/>
-          <ac:spMkLst>
-            <pc:docMk/>
-            <pc:sldMk cId="936306167" sldId="306"/>
-            <ac:spMk id="2" creationId="{1CBACC95-7B5D-B262-13C4-1D6C315A9FA6}"/>
-          </ac:spMkLst>
-        </pc:spChg>
-      </pc:sldChg>
-      <pc:sldChg chg="modSp mod">
-        <pc:chgData name="Shanna Tervoort-McLeod" userId="253d0e36-d0bf-47b4-b4e5-27c32d8025c0" providerId="ADAL" clId="{292B3924-7E15-5699-88F2-F017F785F965}" dt="2026-05-05T21:33:37.857" v="15" actId="20577"/>
-        <pc:sldMkLst>
-          <pc:docMk/>
-          <pc:sldMk cId="2240769710" sldId="307"/>
-        </pc:sldMkLst>
-        <pc:spChg chg="mod">
-          <ac:chgData name="Shanna Tervoort-McLeod" userId="253d0e36-d0bf-47b4-b4e5-27c32d8025c0" providerId="ADAL" clId="{292B3924-7E15-5699-88F2-F017F785F965}" dt="2026-05-05T21:33:37.857" v="15" actId="20577"/>
-          <ac:spMkLst>
-            <pc:docMk/>
-            <pc:sldMk cId="2240769710" sldId="307"/>
-            <ac:spMk id="2" creationId="{021AFA9B-97DA-1E95-BDFF-6B2352F5FE16}"/>
-          </ac:spMkLst>
-        </pc:spChg>
-      </pc:sldChg>
-      <pc:sldChg chg="modSp mod">
-        <pc:chgData name="Shanna Tervoort-McLeod" userId="253d0e36-d0bf-47b4-b4e5-27c32d8025c0" providerId="ADAL" clId="{292B3924-7E15-5699-88F2-F017F785F965}" dt="2026-05-05T21:36:57.412" v="30" actId="1076"/>
-        <pc:sldMkLst>
-          <pc:docMk/>
-          <pc:sldMk cId="3629942069" sldId="309"/>
-        </pc:sldMkLst>
-        <pc:spChg chg="mod">
-          <ac:chgData name="Shanna Tervoort-McLeod" userId="253d0e36-d0bf-47b4-b4e5-27c32d8025c0" providerId="ADAL" clId="{292B3924-7E15-5699-88F2-F017F785F965}" dt="2026-05-05T21:36:57.412" v="30" actId="1076"/>
-          <ac:spMkLst>
-            <pc:docMk/>
-            <pc:sldMk cId="3629942069" sldId="309"/>
-            <ac:spMk id="3" creationId="{E8D4B9B5-24C1-98B7-581B-17A2D90EF571}"/>
-          </ac:spMkLst>
-        </pc:spChg>
-      </pc:sldChg>
-    </pc:docChg>
-  </pc:docChgLst>
-  <pc:docChgLst>
     <pc:chgData name="Nick Snellgrove" userId="S::nick@epi.group::4e108f51-f871-446a-96e9-c587ed0b7a51" providerId="AD" clId="Web-{502D73C1-0A32-21DE-CC5E-EF4E17045E48}"/>
     <pc:docChg chg="addSld delSld modSld sldOrd">
       <pc:chgData name="Nick Snellgrove" userId="S::nick@epi.group::4e108f51-f871-446a-96e9-c587ed0b7a51" providerId="AD" clId="Web-{502D73C1-0A32-21DE-CC5E-EF4E17045E48}" dt="2026-05-01T05:01:50.114" v="1674" actId="20577"/>
@@ -1291,6 +1087,227 @@
             <pc:docMk/>
             <pc:sldMk cId="2723548160" sldId="289"/>
             <ac:spMk id="3" creationId="{C42A2B45-25C9-E5C9-F733-3580062FC60A}"/>
+          </ac:spMkLst>
+        </pc:spChg>
+      </pc:sldChg>
+    </pc:docChg>
+  </pc:docChgLst>
+  <pc:docChgLst>
+    <pc:chgData name="Shanna Tervoort-McLeod" userId="253d0e36-d0bf-47b4-b4e5-27c32d8025c0" providerId="ADAL" clId="{292B3924-7E15-5699-88F2-F017F785F965}"/>
+    <pc:docChg chg="custSel modSld">
+      <pc:chgData name="Shanna Tervoort-McLeod" userId="253d0e36-d0bf-47b4-b4e5-27c32d8025c0" providerId="ADAL" clId="{292B3924-7E15-5699-88F2-F017F785F965}" dt="2026-05-05T23:01:46.030" v="60" actId="1076"/>
+      <pc:docMkLst>
+        <pc:docMk/>
+      </pc:docMkLst>
+      <pc:sldChg chg="modSp mod">
+        <pc:chgData name="Shanna Tervoort-McLeod" userId="253d0e36-d0bf-47b4-b4e5-27c32d8025c0" providerId="ADAL" clId="{292B3924-7E15-5699-88F2-F017F785F965}" dt="2026-05-05T21:29:37.277" v="0" actId="113"/>
+        <pc:sldMkLst>
+          <pc:docMk/>
+          <pc:sldMk cId="3812533663" sldId="256"/>
+        </pc:sldMkLst>
+        <pc:spChg chg="mod">
+          <ac:chgData name="Shanna Tervoort-McLeod" userId="253d0e36-d0bf-47b4-b4e5-27c32d8025c0" providerId="ADAL" clId="{292B3924-7E15-5699-88F2-F017F785F965}" dt="2026-05-05T21:29:37.277" v="0" actId="113"/>
+          <ac:spMkLst>
+            <pc:docMk/>
+            <pc:sldMk cId="3812533663" sldId="256"/>
+            <ac:spMk id="2" creationId="{A46922D6-CA7A-4822-2C87-11A521B48D6C}"/>
+          </ac:spMkLst>
+        </pc:spChg>
+      </pc:sldChg>
+      <pc:sldChg chg="modSp mod">
+        <pc:chgData name="Shanna Tervoort-McLeod" userId="253d0e36-d0bf-47b4-b4e5-27c32d8025c0" providerId="ADAL" clId="{292B3924-7E15-5699-88F2-F017F785F965}" dt="2026-05-05T21:36:03.282" v="23" actId="20577"/>
+        <pc:sldMkLst>
+          <pc:docMk/>
+          <pc:sldMk cId="2723548160" sldId="289"/>
+        </pc:sldMkLst>
+        <pc:spChg chg="mod">
+          <ac:chgData name="Shanna Tervoort-McLeod" userId="253d0e36-d0bf-47b4-b4e5-27c32d8025c0" providerId="ADAL" clId="{292B3924-7E15-5699-88F2-F017F785F965}" dt="2026-05-05T21:36:03.282" v="23" actId="20577"/>
+          <ac:spMkLst>
+            <pc:docMk/>
+            <pc:sldMk cId="2723548160" sldId="289"/>
+            <ac:spMk id="3" creationId="{C42A2B45-25C9-E5C9-F733-3580062FC60A}"/>
+          </ac:spMkLst>
+        </pc:spChg>
+      </pc:sldChg>
+      <pc:sldChg chg="modSp mod">
+        <pc:chgData name="Shanna Tervoort-McLeod" userId="253d0e36-d0bf-47b4-b4e5-27c32d8025c0" providerId="ADAL" clId="{292B3924-7E15-5699-88F2-F017F785F965}" dt="2026-05-05T21:31:11.347" v="1" actId="12"/>
+        <pc:sldMkLst>
+          <pc:docMk/>
+          <pc:sldMk cId="1627143753" sldId="296"/>
+        </pc:sldMkLst>
+        <pc:spChg chg="mod">
+          <ac:chgData name="Shanna Tervoort-McLeod" userId="253d0e36-d0bf-47b4-b4e5-27c32d8025c0" providerId="ADAL" clId="{292B3924-7E15-5699-88F2-F017F785F965}" dt="2026-05-05T21:31:11.347" v="1" actId="12"/>
+          <ac:spMkLst>
+            <pc:docMk/>
+            <pc:sldMk cId="1627143753" sldId="296"/>
+            <ac:spMk id="4" creationId="{7A399886-A7EF-3AFB-834D-E3144844208E}"/>
+          </ac:spMkLst>
+        </pc:spChg>
+      </pc:sldChg>
+      <pc:sldChg chg="addSp modSp mod">
+        <pc:chgData name="Shanna Tervoort-McLeod" userId="253d0e36-d0bf-47b4-b4e5-27c32d8025c0" providerId="ADAL" clId="{292B3924-7E15-5699-88F2-F017F785F965}" dt="2026-05-05T21:37:47.120" v="37" actId="1076"/>
+        <pc:sldMkLst>
+          <pc:docMk/>
+          <pc:sldMk cId="338454694" sldId="299"/>
+        </pc:sldMkLst>
+        <pc:spChg chg="mod">
+          <ac:chgData name="Shanna Tervoort-McLeod" userId="253d0e36-d0bf-47b4-b4e5-27c32d8025c0" providerId="ADAL" clId="{292B3924-7E15-5699-88F2-F017F785F965}" dt="2026-05-05T21:35:47.573" v="20" actId="14100"/>
+          <ac:spMkLst>
+            <pc:docMk/>
+            <pc:sldMk cId="338454694" sldId="299"/>
+            <ac:spMk id="4" creationId="{23025534-4FEA-689C-77C7-F44F76ACC956}"/>
+          </ac:spMkLst>
+        </pc:spChg>
+        <pc:picChg chg="add mod">
+          <ac:chgData name="Shanna Tervoort-McLeod" userId="253d0e36-d0bf-47b4-b4e5-27c32d8025c0" providerId="ADAL" clId="{292B3924-7E15-5699-88F2-F017F785F965}" dt="2026-05-05T21:37:47.120" v="37" actId="1076"/>
+          <ac:picMkLst>
+            <pc:docMk/>
+            <pc:sldMk cId="338454694" sldId="299"/>
+            <ac:picMk id="5" creationId="{FB710EE5-6207-B7A4-36EB-CA0F609EE198}"/>
+          </ac:picMkLst>
+        </pc:picChg>
+      </pc:sldChg>
+      <pc:sldChg chg="addSp modSp mod">
+        <pc:chgData name="Shanna Tervoort-McLeod" userId="253d0e36-d0bf-47b4-b4e5-27c32d8025c0" providerId="ADAL" clId="{292B3924-7E15-5699-88F2-F017F785F965}" dt="2026-05-05T21:45:01.763" v="56" actId="1076"/>
+        <pc:sldMkLst>
+          <pc:docMk/>
+          <pc:sldMk cId="491669475" sldId="301"/>
+        </pc:sldMkLst>
+        <pc:spChg chg="mod">
+          <ac:chgData name="Shanna Tervoort-McLeod" userId="253d0e36-d0bf-47b4-b4e5-27c32d8025c0" providerId="ADAL" clId="{292B3924-7E15-5699-88F2-F017F785F965}" dt="2026-05-05T21:36:35.621" v="28" actId="14100"/>
+          <ac:spMkLst>
+            <pc:docMk/>
+            <pc:sldMk cId="491669475" sldId="301"/>
+            <ac:spMk id="3" creationId="{0BD444BF-6F55-619A-1EE5-FD3B9DC0B403}"/>
+          </ac:spMkLst>
+        </pc:spChg>
+        <pc:picChg chg="add mod">
+          <ac:chgData name="Shanna Tervoort-McLeod" userId="253d0e36-d0bf-47b4-b4e5-27c32d8025c0" providerId="ADAL" clId="{292B3924-7E15-5699-88F2-F017F785F965}" dt="2026-05-05T21:45:01.763" v="56" actId="1076"/>
+          <ac:picMkLst>
+            <pc:docMk/>
+            <pc:sldMk cId="491669475" sldId="301"/>
+            <ac:picMk id="4" creationId="{65A64BC6-2670-5588-CD05-270E75A70649}"/>
+          </ac:picMkLst>
+        </pc:picChg>
+      </pc:sldChg>
+      <pc:sldChg chg="modSp mod">
+        <pc:chgData name="Shanna Tervoort-McLeod" userId="253d0e36-d0bf-47b4-b4e5-27c32d8025c0" providerId="ADAL" clId="{292B3924-7E15-5699-88F2-F017F785F965}" dt="2026-05-05T21:32:43.650" v="10" actId="20577"/>
+        <pc:sldMkLst>
+          <pc:docMk/>
+          <pc:sldMk cId="2369738800" sldId="302"/>
+        </pc:sldMkLst>
+        <pc:spChg chg="mod">
+          <ac:chgData name="Shanna Tervoort-McLeod" userId="253d0e36-d0bf-47b4-b4e5-27c32d8025c0" providerId="ADAL" clId="{292B3924-7E15-5699-88F2-F017F785F965}" dt="2026-05-05T21:32:43.650" v="10" actId="20577"/>
+          <ac:spMkLst>
+            <pc:docMk/>
+            <pc:sldMk cId="2369738800" sldId="302"/>
+            <ac:spMk id="2" creationId="{C011AEAB-AA53-5478-E484-A35881BD8E2A}"/>
+          </ac:spMkLst>
+        </pc:spChg>
+      </pc:sldChg>
+      <pc:sldChg chg="modSp mod">
+        <pc:chgData name="Shanna Tervoort-McLeod" userId="253d0e36-d0bf-47b4-b4e5-27c32d8025c0" providerId="ADAL" clId="{292B3924-7E15-5699-88F2-F017F785F965}" dt="2026-05-05T21:32:56.022" v="12" actId="20577"/>
+        <pc:sldMkLst>
+          <pc:docMk/>
+          <pc:sldMk cId="2103267894" sldId="303"/>
+        </pc:sldMkLst>
+        <pc:spChg chg="mod">
+          <ac:chgData name="Shanna Tervoort-McLeod" userId="253d0e36-d0bf-47b4-b4e5-27c32d8025c0" providerId="ADAL" clId="{292B3924-7E15-5699-88F2-F017F785F965}" dt="2026-05-05T21:32:56.022" v="12" actId="20577"/>
+          <ac:spMkLst>
+            <pc:docMk/>
+            <pc:sldMk cId="2103267894" sldId="303"/>
+            <ac:spMk id="2" creationId="{AD2C492B-184C-0B13-B356-4A1ED7940BC5}"/>
+          </ac:spMkLst>
+        </pc:spChg>
+      </pc:sldChg>
+      <pc:sldChg chg="addSp modSp mod">
+        <pc:chgData name="Shanna Tervoort-McLeod" userId="253d0e36-d0bf-47b4-b4e5-27c32d8025c0" providerId="ADAL" clId="{292B3924-7E15-5699-88F2-F017F785F965}" dt="2026-05-05T21:42:10.601" v="49" actId="1076"/>
+        <pc:sldMkLst>
+          <pc:docMk/>
+          <pc:sldMk cId="2215040014" sldId="305"/>
+        </pc:sldMkLst>
+        <pc:spChg chg="mod">
+          <ac:chgData name="Shanna Tervoort-McLeod" userId="253d0e36-d0bf-47b4-b4e5-27c32d8025c0" providerId="ADAL" clId="{292B3924-7E15-5699-88F2-F017F785F965}" dt="2026-05-05T21:40:42.651" v="39" actId="27636"/>
+          <ac:spMkLst>
+            <pc:docMk/>
+            <pc:sldMk cId="2215040014" sldId="305"/>
+            <ac:spMk id="3" creationId="{38B7C271-EA34-8727-38AB-6A855D64399D}"/>
+          </ac:spMkLst>
+        </pc:spChg>
+        <pc:picChg chg="add mod">
+          <ac:chgData name="Shanna Tervoort-McLeod" userId="253d0e36-d0bf-47b4-b4e5-27c32d8025c0" providerId="ADAL" clId="{292B3924-7E15-5699-88F2-F017F785F965}" dt="2026-05-05T21:42:10.601" v="49" actId="1076"/>
+          <ac:picMkLst>
+            <pc:docMk/>
+            <pc:sldMk cId="2215040014" sldId="305"/>
+            <ac:picMk id="4" creationId="{A0FD42A8-CD31-47B8-B0D6-CD485E3F2824}"/>
+          </ac:picMkLst>
+        </pc:picChg>
+        <pc:picChg chg="add mod">
+          <ac:chgData name="Shanna Tervoort-McLeod" userId="253d0e36-d0bf-47b4-b4e5-27c32d8025c0" providerId="ADAL" clId="{292B3924-7E15-5699-88F2-F017F785F965}" dt="2026-05-05T21:42:10.601" v="49" actId="1076"/>
+          <ac:picMkLst>
+            <pc:docMk/>
+            <pc:sldMk cId="2215040014" sldId="305"/>
+            <ac:picMk id="5" creationId="{E2146A93-A7CD-7000-66B4-4C5BE939DA6E}"/>
+          </ac:picMkLst>
+        </pc:picChg>
+      </pc:sldChg>
+      <pc:sldChg chg="modSp mod">
+        <pc:chgData name="Shanna Tervoort-McLeod" userId="253d0e36-d0bf-47b4-b4e5-27c32d8025c0" providerId="ADAL" clId="{292B3924-7E15-5699-88F2-F017F785F965}" dt="2026-05-05T21:33:34.212" v="14" actId="20577"/>
+        <pc:sldMkLst>
+          <pc:docMk/>
+          <pc:sldMk cId="936306167" sldId="306"/>
+        </pc:sldMkLst>
+        <pc:spChg chg="mod">
+          <ac:chgData name="Shanna Tervoort-McLeod" userId="253d0e36-d0bf-47b4-b4e5-27c32d8025c0" providerId="ADAL" clId="{292B3924-7E15-5699-88F2-F017F785F965}" dt="2026-05-05T21:33:34.212" v="14" actId="20577"/>
+          <ac:spMkLst>
+            <pc:docMk/>
+            <pc:sldMk cId="936306167" sldId="306"/>
+            <ac:spMk id="2" creationId="{1CBACC95-7B5D-B262-13C4-1D6C315A9FA6}"/>
+          </ac:spMkLst>
+        </pc:spChg>
+      </pc:sldChg>
+      <pc:sldChg chg="modSp mod">
+        <pc:chgData name="Shanna Tervoort-McLeod" userId="253d0e36-d0bf-47b4-b4e5-27c32d8025c0" providerId="ADAL" clId="{292B3924-7E15-5699-88F2-F017F785F965}" dt="2026-05-05T21:33:37.857" v="15" actId="20577"/>
+        <pc:sldMkLst>
+          <pc:docMk/>
+          <pc:sldMk cId="2240769710" sldId="307"/>
+        </pc:sldMkLst>
+        <pc:spChg chg="mod">
+          <ac:chgData name="Shanna Tervoort-McLeod" userId="253d0e36-d0bf-47b4-b4e5-27c32d8025c0" providerId="ADAL" clId="{292B3924-7E15-5699-88F2-F017F785F965}" dt="2026-05-05T21:33:37.857" v="15" actId="20577"/>
+          <ac:spMkLst>
+            <pc:docMk/>
+            <pc:sldMk cId="2240769710" sldId="307"/>
+            <ac:spMk id="2" creationId="{021AFA9B-97DA-1E95-BDFF-6B2352F5FE16}"/>
+          </ac:spMkLst>
+        </pc:spChg>
+      </pc:sldChg>
+      <pc:sldChg chg="modSp mod">
+        <pc:chgData name="Shanna Tervoort-McLeod" userId="253d0e36-d0bf-47b4-b4e5-27c32d8025c0" providerId="ADAL" clId="{292B3924-7E15-5699-88F2-F017F785F965}" dt="2026-05-05T21:36:57.412" v="30" actId="1076"/>
+        <pc:sldMkLst>
+          <pc:docMk/>
+          <pc:sldMk cId="3629942069" sldId="309"/>
+        </pc:sldMkLst>
+        <pc:spChg chg="mod">
+          <ac:chgData name="Shanna Tervoort-McLeod" userId="253d0e36-d0bf-47b4-b4e5-27c32d8025c0" providerId="ADAL" clId="{292B3924-7E15-5699-88F2-F017F785F965}" dt="2026-05-05T21:36:57.412" v="30" actId="1076"/>
+          <ac:spMkLst>
+            <pc:docMk/>
+            <pc:sldMk cId="3629942069" sldId="309"/>
+            <ac:spMk id="3" creationId="{E8D4B9B5-24C1-98B7-581B-17A2D90EF571}"/>
+          </ac:spMkLst>
+        </pc:spChg>
+      </pc:sldChg>
+      <pc:sldChg chg="modSp mod">
+        <pc:chgData name="Shanna Tervoort-McLeod" userId="253d0e36-d0bf-47b4-b4e5-27c32d8025c0" providerId="ADAL" clId="{292B3924-7E15-5699-88F2-F017F785F965}" dt="2026-05-05T23:01:46.030" v="60" actId="1076"/>
+        <pc:sldMkLst>
+          <pc:docMk/>
+          <pc:sldMk cId="4081741384" sldId="311"/>
+        </pc:sldMkLst>
+        <pc:spChg chg="mod">
+          <ac:chgData name="Shanna Tervoort-McLeod" userId="253d0e36-d0bf-47b4-b4e5-27c32d8025c0" providerId="ADAL" clId="{292B3924-7E15-5699-88F2-F017F785F965}" dt="2026-05-05T23:01:46.030" v="60" actId="1076"/>
+          <ac:spMkLst>
+            <pc:docMk/>
+            <pc:sldMk cId="4081741384" sldId="311"/>
+            <ac:spMk id="3" creationId="{B24BCF1B-5ADC-68D3-A294-BFF67BC88517}"/>
           </ac:spMkLst>
         </pc:spChg>
       </pc:sldChg>
@@ -1330,6 +1347,30 @@
             <pc:docMk/>
             <pc:sldMk cId="842325243" sldId="267"/>
             <ac:spMk id="2" creationId="{F08F55E4-9F92-903C-8D27-3B06A7283D98}"/>
+          </ac:spMkLst>
+        </pc:spChg>
+      </pc:sldChg>
+    </pc:docChg>
+  </pc:docChgLst>
+  <pc:docChgLst>
+    <pc:chgData name="Steven Simpson" userId="S::steven@epi.group::da5739ee-a425-42de-9941-9a9e46b7e9a3" providerId="AD" clId="Web-{5A8A33D3-215F-8A95-79C7-55071864AF8B}"/>
+    <pc:docChg chg="modSld">
+      <pc:chgData name="Steven Simpson" userId="S::steven@epi.group::da5739ee-a425-42de-9941-9a9e46b7e9a3" providerId="AD" clId="Web-{5A8A33D3-215F-8A95-79C7-55071864AF8B}" dt="2026-05-05T02:01:56.717" v="65" actId="20577"/>
+      <pc:docMkLst>
+        <pc:docMk/>
+      </pc:docMkLst>
+      <pc:sldChg chg="modSp">
+        <pc:chgData name="Steven Simpson" userId="S::steven@epi.group::da5739ee-a425-42de-9941-9a9e46b7e9a3" providerId="AD" clId="Web-{5A8A33D3-215F-8A95-79C7-55071864AF8B}" dt="2026-05-05T02:01:56.717" v="65" actId="20577"/>
+        <pc:sldMkLst>
+          <pc:docMk/>
+          <pc:sldMk cId="3899449247" sldId="295"/>
+        </pc:sldMkLst>
+        <pc:spChg chg="mod">
+          <ac:chgData name="Steven Simpson" userId="S::steven@epi.group::da5739ee-a425-42de-9941-9a9e46b7e9a3" providerId="AD" clId="Web-{5A8A33D3-215F-8A95-79C7-55071864AF8B}" dt="2026-05-05T02:01:56.717" v="65" actId="20577"/>
+          <ac:spMkLst>
+            <pc:docMk/>
+            <pc:sldMk cId="3899449247" sldId="295"/>
+            <ac:spMk id="6" creationId="{60FB406B-CED1-E8A6-97A1-533706741827}"/>
           </ac:spMkLst>
         </pc:spChg>
       </pc:sldChg>
@@ -1462,24 +1503,62 @@
     </pc:docChg>
   </pc:docChgLst>
   <pc:docChgLst>
-    <pc:chgData name="Steven Simpson" userId="S::steven@epi.group::da5739ee-a425-42de-9941-9a9e46b7e9a3" providerId="AD" clId="Web-{5A8A33D3-215F-8A95-79C7-55071864AF8B}"/>
-    <pc:docChg chg="modSld">
-      <pc:chgData name="Steven Simpson" userId="S::steven@epi.group::da5739ee-a425-42de-9941-9a9e46b7e9a3" providerId="AD" clId="Web-{5A8A33D3-215F-8A95-79C7-55071864AF8B}" dt="2026-05-05T02:01:56.717" v="65" actId="20577"/>
+    <pc:chgData name="Steven Simpson" userId="S::steven@epi.group::da5739ee-a425-42de-9941-9a9e46b7e9a3" providerId="AD" clId="Web-{EDE0496E-E3D2-885E-396E-EB539D8668C1}"/>
+    <pc:docChg chg="addSld delSld modSld sldOrd">
+      <pc:chgData name="Steven Simpson" userId="S::steven@epi.group::da5739ee-a425-42de-9941-9a9e46b7e9a3" providerId="AD" clId="Web-{EDE0496E-E3D2-885E-396E-EB539D8668C1}" dt="2026-05-05T22:56:06.090" v="64" actId="1076"/>
       <pc:docMkLst>
         <pc:docMk/>
       </pc:docMkLst>
-      <pc:sldChg chg="modSp">
-        <pc:chgData name="Steven Simpson" userId="S::steven@epi.group::da5739ee-a425-42de-9941-9a9e46b7e9a3" providerId="AD" clId="Web-{5A8A33D3-215F-8A95-79C7-55071864AF8B}" dt="2026-05-05T02:01:56.717" v="65" actId="20577"/>
+      <pc:sldChg chg="addSp delSp modSp del">
+        <pc:chgData name="Steven Simpson" userId="S::steven@epi.group::da5739ee-a425-42de-9941-9a9e46b7e9a3" providerId="AD" clId="Web-{EDE0496E-E3D2-885E-396E-EB539D8668C1}" dt="2026-05-05T22:41:20.285" v="13"/>
         <pc:sldMkLst>
           <pc:docMk/>
-          <pc:sldMk cId="3899449247" sldId="295"/>
+          <pc:sldMk cId="2369738800" sldId="302"/>
         </pc:sldMkLst>
         <pc:spChg chg="mod">
-          <ac:chgData name="Steven Simpson" userId="S::steven@epi.group::da5739ee-a425-42de-9941-9a9e46b7e9a3" providerId="AD" clId="Web-{5A8A33D3-215F-8A95-79C7-55071864AF8B}" dt="2026-05-05T02:01:56.717" v="65" actId="20577"/>
+          <ac:chgData name="Steven Simpson" userId="S::steven@epi.group::da5739ee-a425-42de-9941-9a9e46b7e9a3" providerId="AD" clId="Web-{EDE0496E-E3D2-885E-396E-EB539D8668C1}" dt="2026-05-05T22:40:59.253" v="9" actId="1076"/>
           <ac:spMkLst>
             <pc:docMk/>
-            <pc:sldMk cId="3899449247" sldId="295"/>
-            <ac:spMk id="6" creationId="{60FB406B-CED1-E8A6-97A1-533706741827}"/>
+            <pc:sldMk cId="2369738800" sldId="302"/>
+            <ac:spMk id="2" creationId="{C011AEAB-AA53-5478-E484-A35881BD8E2A}"/>
+          </ac:spMkLst>
+        </pc:spChg>
+        <pc:spChg chg="add del">
+          <ac:chgData name="Steven Simpson" userId="S::steven@epi.group::da5739ee-a425-42de-9941-9a9e46b7e9a3" providerId="AD" clId="Web-{EDE0496E-E3D2-885E-396E-EB539D8668C1}" dt="2026-05-05T22:41:09.535" v="11"/>
+          <ac:spMkLst>
+            <pc:docMk/>
+            <pc:sldMk cId="2369738800" sldId="302"/>
+            <ac:spMk id="3" creationId="{28C5BCEA-7778-8F24-3105-B2E296512268}"/>
+          </ac:spMkLst>
+        </pc:spChg>
+      </pc:sldChg>
+      <pc:sldChg chg="add replId">
+        <pc:chgData name="Steven Simpson" userId="S::steven@epi.group::da5739ee-a425-42de-9941-9a9e46b7e9a3" providerId="AD" clId="Web-{EDE0496E-E3D2-885E-396E-EB539D8668C1}" dt="2026-05-05T22:40:41.800" v="0"/>
+        <pc:sldMkLst>
+          <pc:docMk/>
+          <pc:sldMk cId="1770924310" sldId="310"/>
+        </pc:sldMkLst>
+      </pc:sldChg>
+      <pc:sldChg chg="modSp add ord replId">
+        <pc:chgData name="Steven Simpson" userId="S::steven@epi.group::da5739ee-a425-42de-9941-9a9e46b7e9a3" providerId="AD" clId="Web-{EDE0496E-E3D2-885E-396E-EB539D8668C1}" dt="2026-05-05T22:56:06.090" v="64" actId="1076"/>
+        <pc:sldMkLst>
+          <pc:docMk/>
+          <pc:sldMk cId="4081741384" sldId="311"/>
+        </pc:sldMkLst>
+        <pc:spChg chg="mod">
+          <ac:chgData name="Steven Simpson" userId="S::steven@epi.group::da5739ee-a425-42de-9941-9a9e46b7e9a3" providerId="AD" clId="Web-{EDE0496E-E3D2-885E-396E-EB539D8668C1}" dt="2026-05-05T22:56:06.090" v="64" actId="1076"/>
+          <ac:spMkLst>
+            <pc:docMk/>
+            <pc:sldMk cId="4081741384" sldId="311"/>
+            <ac:spMk id="2" creationId="{33E9874E-9F57-E34B-B21E-D597E949434E}"/>
+          </ac:spMkLst>
+        </pc:spChg>
+        <pc:spChg chg="mod">
+          <ac:chgData name="Steven Simpson" userId="S::steven@epi.group::da5739ee-a425-42de-9941-9a9e46b7e9a3" providerId="AD" clId="Web-{EDE0496E-E3D2-885E-396E-EB539D8668C1}" dt="2026-05-05T22:55:27.511" v="63" actId="20577"/>
+          <ac:spMkLst>
+            <pc:docMk/>
+            <pc:sldMk cId="4081741384" sldId="311"/>
+            <ac:spMk id="3" creationId="{B24BCF1B-5ADC-68D3-A294-BFF67BC88517}"/>
           </ac:spMkLst>
         </pc:spChg>
       </pc:sldChg>
@@ -1936,7 +2015,7 @@
         <p:cNvPr id="1" name="">
           <a:extLst>
             <a:ext uri="{FF2B5EF4-FFF2-40B4-BE49-F238E27FC236}">
-              <a16:creationId xmlns:a16="http://schemas.microsoft.com/office/drawing/2014/main" id="{449DE461-E104-61BE-916E-0380A2F58567}"/>
+              <a16:creationId xmlns:a16="http://schemas.microsoft.com/office/drawing/2014/main" id="{EDBE71C3-3AA9-5902-D82E-F909A9FB643F}"/>
             </a:ext>
           </a:extLst>
         </p:cNvPr>
@@ -1956,7 +2035,7 @@
           <p:cNvPr id="2" name="Slide Image Placeholder 1">
             <a:extLst>
               <a:ext uri="{FF2B5EF4-FFF2-40B4-BE49-F238E27FC236}">
-                <a16:creationId xmlns:a16="http://schemas.microsoft.com/office/drawing/2014/main" id="{B3896A42-D332-C945-255B-D128320CA092}"/>
+                <a16:creationId xmlns:a16="http://schemas.microsoft.com/office/drawing/2014/main" id="{B5C7E88D-7F23-398B-AF71-EB3EA3D4F550}"/>
               </a:ext>
             </a:extLst>
           </p:cNvPr>
@@ -1974,7 +2053,7 @@
           <p:cNvPr id="3" name="Notes Placeholder 2">
             <a:extLst>
               <a:ext uri="{FF2B5EF4-FFF2-40B4-BE49-F238E27FC236}">
-                <a16:creationId xmlns:a16="http://schemas.microsoft.com/office/drawing/2014/main" id="{03115F8C-37A3-0206-79C8-3F43CA66C92B}"/>
+                <a16:creationId xmlns:a16="http://schemas.microsoft.com/office/drawing/2014/main" id="{5253273B-89DD-5B46-D059-8430A46502A1}"/>
               </a:ext>
             </a:extLst>
           </p:cNvPr>
@@ -2009,7 +2088,7 @@
           <p:cNvPr id="4" name="Slide Number Placeholder 3">
             <a:extLst>
               <a:ext uri="{FF2B5EF4-FFF2-40B4-BE49-F238E27FC236}">
-                <a16:creationId xmlns:a16="http://schemas.microsoft.com/office/drawing/2014/main" id="{8C241D4D-08AB-834A-E93A-78384A8A8089}"/>
+                <a16:creationId xmlns:a16="http://schemas.microsoft.com/office/drawing/2014/main" id="{018FCBA8-F969-AB71-5DAA-2CBD2DECA466}"/>
               </a:ext>
             </a:extLst>
           </p:cNvPr>
@@ -2035,7 +2114,7 @@
     </p:spTree>
     <p:extLst>
       <p:ext uri="{BB962C8B-B14F-4D97-AF65-F5344CB8AC3E}">
-        <p14:creationId xmlns:p14="http://schemas.microsoft.com/office/powerpoint/2010/main" val="743479819"/>
+        <p14:creationId xmlns:p14="http://schemas.microsoft.com/office/powerpoint/2010/main" val="1116122631"/>
       </p:ext>
     </p:extLst>
   </p:cSld>
@@ -2046,6 +2125,123 @@
 </file>
 
 <file path=ppt/notesSlides/notesSlide3.xml><?xml version="1.0" encoding="utf-8"?>
+<p:notes xmlns:a="http://schemas.openxmlformats.org/drawingml/2006/main" xmlns:r="http://schemas.openxmlformats.org/officeDocument/2006/relationships" xmlns:p="http://schemas.openxmlformats.org/presentationml/2006/main">
+  <p:cSld>
+    <p:spTree>
+      <p:nvGrpSpPr>
+        <p:cNvPr id="1" name="">
+          <a:extLst>
+            <a:ext uri="{FF2B5EF4-FFF2-40B4-BE49-F238E27FC236}">
+              <a16:creationId xmlns:a16="http://schemas.microsoft.com/office/drawing/2014/main" id="{D2C6E8DE-B80F-9EF2-B658-BE8E9BBE7DAD}"/>
+            </a:ext>
+          </a:extLst>
+        </p:cNvPr>
+        <p:cNvGrpSpPr/>
+        <p:nvPr/>
+      </p:nvGrpSpPr>
+      <p:grpSpPr>
+        <a:xfrm>
+          <a:off x="0" y="0"/>
+          <a:ext cx="0" cy="0"/>
+          <a:chOff x="0" y="0"/>
+          <a:chExt cx="0" cy="0"/>
+        </a:xfrm>
+      </p:grpSpPr>
+      <p:sp>
+        <p:nvSpPr>
+          <p:cNvPr id="2" name="Slide Image Placeholder 1">
+            <a:extLst>
+              <a:ext uri="{FF2B5EF4-FFF2-40B4-BE49-F238E27FC236}">
+                <a16:creationId xmlns:a16="http://schemas.microsoft.com/office/drawing/2014/main" id="{9D39B978-4B2A-8191-F69A-375ED6D8F39E}"/>
+              </a:ext>
+            </a:extLst>
+          </p:cNvPr>
+          <p:cNvSpPr>
+            <a:spLocks noGrp="1" noRot="1" noChangeAspect="1"/>
+          </p:cNvSpPr>
+          <p:nvPr>
+            <p:ph type="sldImg"/>
+          </p:nvPr>
+        </p:nvSpPr>
+        <p:spPr/>
+      </p:sp>
+      <p:sp>
+        <p:nvSpPr>
+          <p:cNvPr id="3" name="Notes Placeholder 2">
+            <a:extLst>
+              <a:ext uri="{FF2B5EF4-FFF2-40B4-BE49-F238E27FC236}">
+                <a16:creationId xmlns:a16="http://schemas.microsoft.com/office/drawing/2014/main" id="{91A5B652-C602-748B-52A5-9CE48EEF8793}"/>
+              </a:ext>
+            </a:extLst>
+          </p:cNvPr>
+          <p:cNvSpPr>
+            <a:spLocks noGrp="1"/>
+          </p:cNvSpPr>
+          <p:nvPr>
+            <p:ph type="body" idx="1"/>
+          </p:nvPr>
+        </p:nvSpPr>
+        <p:spPr/>
+        <p:txBody>
+          <a:bodyPr/>
+          <a:lstStyle/>
+          <a:p>
+            <a:endParaRPr lang="en-US">
+              <a:solidFill>
+                <a:srgbClr val="444444"/>
+              </a:solidFill>
+            </a:endParaRPr>
+          </a:p>
+          <a:p>
+            <a:endParaRPr lang="en-US">
+              <a:ea typeface="Calibri"/>
+              <a:cs typeface="Calibri"/>
+            </a:endParaRPr>
+          </a:p>
+        </p:txBody>
+      </p:sp>
+      <p:sp>
+        <p:nvSpPr>
+          <p:cNvPr id="4" name="Slide Number Placeholder 3">
+            <a:extLst>
+              <a:ext uri="{FF2B5EF4-FFF2-40B4-BE49-F238E27FC236}">
+                <a16:creationId xmlns:a16="http://schemas.microsoft.com/office/drawing/2014/main" id="{4E04F807-1671-BF7F-0AB6-74F253699ACA}"/>
+              </a:ext>
+            </a:extLst>
+          </p:cNvPr>
+          <p:cNvSpPr>
+            <a:spLocks noGrp="1"/>
+          </p:cNvSpPr>
+          <p:nvPr>
+            <p:ph type="sldNum" sz="quarter" idx="5"/>
+          </p:nvPr>
+        </p:nvSpPr>
+        <p:spPr/>
+        <p:txBody>
+          <a:bodyPr/>
+          <a:lstStyle/>
+          <a:p>
+            <a:fld id="{259FAD9A-6581-49B4-8B2D-31E20AFC6A7E}" type="slidenum">
+              <a:t>10</a:t>
+            </a:fld>
+            <a:endParaRPr lang="en-US"/>
+          </a:p>
+        </p:txBody>
+      </p:sp>
+    </p:spTree>
+    <p:extLst>
+      <p:ext uri="{BB962C8B-B14F-4D97-AF65-F5344CB8AC3E}">
+        <p14:creationId xmlns:p14="http://schemas.microsoft.com/office/powerpoint/2010/main" val="2868560733"/>
+      </p:ext>
+    </p:extLst>
+  </p:cSld>
+  <p:clrMapOvr>
+    <a:masterClrMapping/>
+  </p:clrMapOvr>
+</p:notes>
+</file>
+
+<file path=ppt/notesSlides/notesSlide4.xml><?xml version="1.0" encoding="utf-8"?>
 <p:notes xmlns:a="http://schemas.openxmlformats.org/drawingml/2006/main" xmlns:r="http://schemas.openxmlformats.org/officeDocument/2006/relationships" xmlns:p="http://schemas.openxmlformats.org/presentationml/2006/main">
   <p:cSld>
     <p:spTree>
@@ -2143,7 +2339,7 @@
           <a:lstStyle/>
           <a:p>
             <a:fld id="{259FAD9A-6581-49B4-8B2D-31E20AFC6A7E}" type="slidenum">
-              <a:t>11</a:t>
+              <a:t>12</a:t>
             </a:fld>
             <a:endParaRPr lang="en-US"/>
           </a:p>
@@ -2162,7 +2358,7 @@
 </p:notes>
 </file>
 
-<file path=ppt/notesSlides/notesSlide4.xml><?xml version="1.0" encoding="utf-8"?>
+<file path=ppt/notesSlides/notesSlide5.xml><?xml version="1.0" encoding="utf-8"?>
 <p:notes xmlns:a="http://schemas.openxmlformats.org/drawingml/2006/main" xmlns:r="http://schemas.openxmlformats.org/officeDocument/2006/relationships" xmlns:p="http://schemas.openxmlformats.org/presentationml/2006/main">
   <p:cSld>
     <p:spTree>
@@ -2277,7 +2473,7 @@
           <a:lstStyle/>
           <a:p>
             <a:fld id="{259FAD9A-6581-49B4-8B2D-31E20AFC6A7E}" type="slidenum">
-              <a:t>13</a:t>
+              <a:t>14</a:t>
             </a:fld>
             <a:endParaRPr lang="en-US"/>
           </a:p>
@@ -2296,7 +2492,7 @@
 </p:notes>
 </file>
 
-<file path=ppt/notesSlides/notesSlide5.xml><?xml version="1.0" encoding="utf-8"?>
+<file path=ppt/notesSlides/notesSlide6.xml><?xml version="1.0" encoding="utf-8"?>
 <p:notes xmlns:a="http://schemas.openxmlformats.org/drawingml/2006/main" xmlns:r="http://schemas.openxmlformats.org/officeDocument/2006/relationships" xmlns:p="http://schemas.openxmlformats.org/presentationml/2006/main">
   <p:cSld>
     <p:spTree>
@@ -2394,7 +2590,7 @@
           <a:lstStyle/>
           <a:p>
             <a:fld id="{259FAD9A-6581-49B4-8B2D-31E20AFC6A7E}" type="slidenum">
-              <a:t>15</a:t>
+              <a:t>16</a:t>
             </a:fld>
             <a:endParaRPr lang="en-US"/>
           </a:p>
@@ -2413,7 +2609,7 @@
 </p:notes>
 </file>
 
-<file path=ppt/notesSlides/notesSlide6.xml><?xml version="1.0" encoding="utf-8"?>
+<file path=ppt/notesSlides/notesSlide7.xml><?xml version="1.0" encoding="utf-8"?>
 <p:notes xmlns:a="http://schemas.openxmlformats.org/drawingml/2006/main" xmlns:r="http://schemas.openxmlformats.org/officeDocument/2006/relationships" xmlns:p="http://schemas.openxmlformats.org/presentationml/2006/main">
   <p:cSld>
     <p:spTree>
@@ -2511,7 +2707,7 @@
           <a:lstStyle/>
           <a:p>
             <a:fld id="{259FAD9A-6581-49B4-8B2D-31E20AFC6A7E}" type="slidenum">
-              <a:t>17</a:t>
+              <a:t>18</a:t>
             </a:fld>
             <a:endParaRPr lang="en-US"/>
           </a:p>
@@ -8534,6 +8730,75 @@
         <p:cNvPr id="1" name="">
           <a:extLst>
             <a:ext uri="{FF2B5EF4-FFF2-40B4-BE49-F238E27FC236}">
+              <a16:creationId xmlns:a16="http://schemas.microsoft.com/office/drawing/2014/main" id="{034CEC49-432B-E8B1-535D-6DD842D5AA68}"/>
+            </a:ext>
+          </a:extLst>
+        </p:cNvPr>
+        <p:cNvGrpSpPr/>
+        <p:nvPr/>
+      </p:nvGrpSpPr>
+      <p:grpSpPr>
+        <a:xfrm>
+          <a:off x="0" y="0"/>
+          <a:ext cx="0" cy="0"/>
+          <a:chOff x="0" y="0"/>
+          <a:chExt cx="0" cy="0"/>
+        </a:xfrm>
+      </p:grpSpPr>
+      <p:sp>
+        <p:nvSpPr>
+          <p:cNvPr id="2" name="Title 1">
+            <a:extLst>
+              <a:ext uri="{FF2B5EF4-FFF2-40B4-BE49-F238E27FC236}">
+                <a16:creationId xmlns:a16="http://schemas.microsoft.com/office/drawing/2014/main" id="{19A05AB9-1DC4-FE20-7683-2D06AED03471}"/>
+              </a:ext>
+            </a:extLst>
+          </p:cNvPr>
+          <p:cNvSpPr>
+            <a:spLocks noGrp="1"/>
+          </p:cNvSpPr>
+          <p:nvPr>
+            <p:ph type="title"/>
+          </p:nvPr>
+        </p:nvSpPr>
+        <p:spPr>
+          <a:xfrm>
+            <a:off x="838200" y="1892808"/>
+            <a:ext cx="10515600" cy="1536192"/>
+          </a:xfrm>
+        </p:spPr>
+        <p:txBody>
+          <a:bodyPr/>
+          <a:lstStyle/>
+          <a:p>
+            <a:r>
+              <a:rPr lang="en-US"/>
+              <a:t>Any questions?</a:t>
+            </a:r>
+          </a:p>
+        </p:txBody>
+      </p:sp>
+    </p:spTree>
+    <p:extLst>
+      <p:ext uri="{BB962C8B-B14F-4D97-AF65-F5344CB8AC3E}">
+        <p14:creationId xmlns:p14="http://schemas.microsoft.com/office/powerpoint/2010/main" val="1770924310"/>
+      </p:ext>
+    </p:extLst>
+  </p:cSld>
+  <p:clrMapOvr>
+    <a:masterClrMapping/>
+  </p:clrMapOvr>
+</p:sld>
+</file>
+
+<file path=ppt/slides/slide11.xml><?xml version="1.0" encoding="utf-8"?>
+<p:sld xmlns:a="http://schemas.openxmlformats.org/drawingml/2006/main" xmlns:r="http://schemas.openxmlformats.org/officeDocument/2006/relationships" xmlns:p="http://schemas.openxmlformats.org/presentationml/2006/main">
+  <p:cSld>
+    <p:spTree>
+      <p:nvGrpSpPr>
+        <p:cNvPr id="1" name="">
+          <a:extLst>
+            <a:ext uri="{FF2B5EF4-FFF2-40B4-BE49-F238E27FC236}">
               <a16:creationId xmlns:a16="http://schemas.microsoft.com/office/drawing/2014/main" id="{4EC43EA9-CF0F-4019-F97A-7F2CAA96E727}"/>
             </a:ext>
           </a:extLst>
@@ -8595,7 +8860,7 @@
 </p:sld>
 </file>
 
-<file path=ppt/slides/slide11.xml><?xml version="1.0" encoding="utf-8"?>
+<file path=ppt/slides/slide12.xml><?xml version="1.0" encoding="utf-8"?>
 <p:sld xmlns:a="http://schemas.openxmlformats.org/drawingml/2006/main" xmlns:r="http://schemas.openxmlformats.org/officeDocument/2006/relationships" xmlns:p="http://schemas.openxmlformats.org/presentationml/2006/main">
   <p:cSld>
     <p:spTree>
@@ -8744,7 +9009,7 @@
 </p:sld>
 </file>
 
-<file path=ppt/slides/slide12.xml><?xml version="1.0" encoding="utf-8"?>
+<file path=ppt/slides/slide13.xml><?xml version="1.0" encoding="utf-8"?>
 <p:sld xmlns:a="http://schemas.openxmlformats.org/drawingml/2006/main" xmlns:r="http://schemas.openxmlformats.org/officeDocument/2006/relationships" xmlns:p="http://schemas.openxmlformats.org/presentationml/2006/main">
   <p:cSld>
     <p:spTree>
@@ -8809,7 +9074,7 @@
 </p:sld>
 </file>
 
-<file path=ppt/slides/slide13.xml><?xml version="1.0" encoding="utf-8"?>
+<file path=ppt/slides/slide14.xml><?xml version="1.0" encoding="utf-8"?>
 <p:sld xmlns:a="http://schemas.openxmlformats.org/drawingml/2006/main" xmlns:r="http://schemas.openxmlformats.org/officeDocument/2006/relationships" xmlns:p="http://schemas.openxmlformats.org/presentationml/2006/main">
   <p:cSld>
     <p:spTree>
@@ -8878,7 +9143,7 @@
 </p:sld>
 </file>
 
-<file path=ppt/slides/slide14.xml><?xml version="1.0" encoding="utf-8"?>
+<file path=ppt/slides/slide15.xml><?xml version="1.0" encoding="utf-8"?>
 <p:sld xmlns:a="http://schemas.openxmlformats.org/drawingml/2006/main" xmlns:r="http://schemas.openxmlformats.org/officeDocument/2006/relationships" xmlns:p="http://schemas.openxmlformats.org/presentationml/2006/main">
   <p:cSld>
     <p:spTree>
@@ -8943,7 +9208,7 @@
 </p:sld>
 </file>
 
-<file path=ppt/slides/slide15.xml><?xml version="1.0" encoding="utf-8"?>
+<file path=ppt/slides/slide16.xml><?xml version="1.0" encoding="utf-8"?>
 <p:sld xmlns:a="http://schemas.openxmlformats.org/drawingml/2006/main" xmlns:r="http://schemas.openxmlformats.org/officeDocument/2006/relationships" xmlns:p="http://schemas.openxmlformats.org/presentationml/2006/main">
   <p:cSld>
     <p:spTree>
@@ -9118,7 +9383,7 @@
 </p:sld>
 </file>
 
-<file path=ppt/slides/slide16.xml><?xml version="1.0" encoding="utf-8"?>
+<file path=ppt/slides/slide17.xml><?xml version="1.0" encoding="utf-8"?>
 <p:sld xmlns:a="http://schemas.openxmlformats.org/drawingml/2006/main" xmlns:r="http://schemas.openxmlformats.org/officeDocument/2006/relationships" xmlns:p="http://schemas.openxmlformats.org/presentationml/2006/main">
   <p:cSld>
     <p:spTree>
@@ -9228,7 +9493,7 @@
 </p:sld>
 </file>
 
-<file path=ppt/slides/slide17.xml><?xml version="1.0" encoding="utf-8"?>
+<file path=ppt/slides/slide18.xml><?xml version="1.0" encoding="utf-8"?>
 <p:sld xmlns:a="http://schemas.openxmlformats.org/drawingml/2006/main" xmlns:r="http://schemas.openxmlformats.org/officeDocument/2006/relationships" xmlns:p="http://schemas.openxmlformats.org/presentationml/2006/main">
   <p:cSld>
     <p:spTree>
@@ -10847,7 +11112,7 @@
         <p:cNvPr id="1" name="">
           <a:extLst>
             <a:ext uri="{FF2B5EF4-FFF2-40B4-BE49-F238E27FC236}">
-              <a16:creationId xmlns:a16="http://schemas.microsoft.com/office/drawing/2014/main" id="{A0EF9D7D-29DF-B8C2-41B8-FF67FF95C219}"/>
+              <a16:creationId xmlns:a16="http://schemas.microsoft.com/office/drawing/2014/main" id="{6899DEBC-4B4D-C60E-A5CA-A6C6B4E89BBE}"/>
             </a:ext>
           </a:extLst>
         </p:cNvPr>
@@ -10867,7 +11132,7 @@
           <p:cNvPr id="2" name="Title 1">
             <a:extLst>
               <a:ext uri="{FF2B5EF4-FFF2-40B4-BE49-F238E27FC236}">
-                <a16:creationId xmlns:a16="http://schemas.microsoft.com/office/drawing/2014/main" id="{C011AEAB-AA53-5478-E484-A35881BD8E2A}"/>
+                <a16:creationId xmlns:a16="http://schemas.microsoft.com/office/drawing/2014/main" id="{33E9874E-9F57-E34B-B21E-D597E949434E}"/>
               </a:ext>
             </a:extLst>
           </p:cNvPr>
@@ -10880,25 +11145,160 @@
         </p:nvSpPr>
         <p:spPr>
           <a:xfrm>
-            <a:off x="838200" y="1892808"/>
-            <a:ext cx="10515600" cy="1536192"/>
+            <a:off x="691662" y="341924"/>
+            <a:ext cx="10662139" cy="852346"/>
           </a:xfrm>
         </p:spPr>
         <p:txBody>
-          <a:bodyPr/>
+          <a:bodyPr>
+            <a:normAutofit fontScale="90000"/>
+          </a:bodyPr>
           <a:lstStyle/>
           <a:p>
             <a:r>
-              <a:rPr lang="en-US"/>
-              <a:t>Any questions?</a:t>
-            </a:r>
+              <a:rPr lang="en-US">
+                <a:latin typeface="Georgia"/>
+              </a:rPr>
+              <a:t>Create or use a GitHub account to follow along</a:t>
+            </a:r>
+            <a:endParaRPr lang="en-US"/>
+          </a:p>
+        </p:txBody>
+      </p:sp>
+      <p:sp>
+        <p:nvSpPr>
+          <p:cNvPr id="3" name="Content Placeholder 2">
+            <a:extLst>
+              <a:ext uri="{FF2B5EF4-FFF2-40B4-BE49-F238E27FC236}">
+                <a16:creationId xmlns:a16="http://schemas.microsoft.com/office/drawing/2014/main" id="{B24BCF1B-5ADC-68D3-A294-BFF67BC88517}"/>
+              </a:ext>
+            </a:extLst>
+          </p:cNvPr>
+          <p:cNvSpPr>
+            <a:spLocks noGrp="1"/>
+          </p:cNvSpPr>
+          <p:nvPr>
+            <p:ph idx="1"/>
+          </p:nvPr>
+        </p:nvSpPr>
+        <p:spPr>
+          <a:xfrm>
+            <a:off x="838200" y="1709878"/>
+            <a:ext cx="10515600" cy="4351338"/>
+          </a:xfrm>
+        </p:spPr>
+        <p:txBody>
+          <a:bodyPr vert="horz" lIns="91440" tIns="45720" rIns="91440" bIns="45720" rtlCol="0" anchor="t">
+            <a:normAutofit/>
+          </a:bodyPr>
+          <a:lstStyle/>
+          <a:p>
+            <a:r>
+              <a:rPr lang="en-US">
+                <a:solidFill>
+                  <a:srgbClr val="404040"/>
+                </a:solidFill>
+                <a:latin typeface="Calibri"/>
+                <a:ea typeface="Calibri"/>
+                <a:cs typeface="Calibri"/>
+              </a:rPr>
+              <a:t>We will be using the recently released marriages, civil unions, and divorces data </a:t>
+            </a:r>
+            <a:br>
+              <a:rPr lang="en-US">
+                <a:solidFill>
+                  <a:srgbClr val="404040"/>
+                </a:solidFill>
+                <a:latin typeface="Calibri"/>
+                <a:ea typeface="Calibri"/>
+                <a:cs typeface="Calibri"/>
+              </a:rPr>
+            </a:br>
+            <a:r>
+              <a:rPr lang="en-US">
+                <a:solidFill>
+                  <a:srgbClr val="404040"/>
+                </a:solidFill>
+                <a:latin typeface="Calibri"/>
+                <a:ea typeface="Calibri"/>
+                <a:cs typeface="Calibri"/>
+                <a:hlinkClick r:id="rId3"/>
+              </a:rPr>
+              <a:t>stats.govt.nz/information-releases/marriages-civil-unions-and-divorces-year-ended-december-2025/</a:t>
+            </a:r>
+            <a:r>
+              <a:rPr lang="en-US">
+                <a:solidFill>
+                  <a:srgbClr val="404040"/>
+                </a:solidFill>
+                <a:latin typeface="Calibri"/>
+                <a:ea typeface="Calibri"/>
+                <a:cs typeface="Calibri"/>
+              </a:rPr>
+              <a:t>  </a:t>
+            </a:r>
+          </a:p>
+          <a:p>
+            <a:pPr marL="0" indent="0">
+              <a:buNone/>
+            </a:pPr>
+            <a:endParaRPr lang="en-US">
+              <a:solidFill>
+                <a:srgbClr val="404040"/>
+              </a:solidFill>
+              <a:latin typeface="Calibri"/>
+              <a:ea typeface="Calibri"/>
+              <a:cs typeface="Calibri"/>
+            </a:endParaRPr>
+          </a:p>
+          <a:p>
+            <a:r>
+              <a:rPr lang="en-US">
+                <a:solidFill>
+                  <a:srgbClr val="404040"/>
+                </a:solidFill>
+                <a:latin typeface="Calibri"/>
+                <a:ea typeface="Calibri"/>
+                <a:cs typeface="Calibri"/>
+              </a:rPr>
+              <a:t>Using a csv downloaded from </a:t>
+            </a:r>
+            <a:r>
+              <a:rPr lang="en-US" i="1" err="1">
+                <a:solidFill>
+                  <a:srgbClr val="404040"/>
+                </a:solidFill>
+                <a:latin typeface="Calibri"/>
+                <a:ea typeface="Calibri"/>
+                <a:cs typeface="Calibri"/>
+              </a:rPr>
+              <a:t>infoshare</a:t>
+            </a:r>
+            <a:r>
+              <a:rPr lang="en-US">
+                <a:solidFill>
+                  <a:srgbClr val="404040"/>
+                </a:solidFill>
+                <a:latin typeface="Calibri"/>
+                <a:ea typeface="Calibri"/>
+                <a:cs typeface="Calibri"/>
+              </a:rPr>
+              <a:t> to get longer timeseries data</a:t>
+            </a:r>
+            <a:endParaRPr lang="en-US"/>
+          </a:p>
+          <a:p>
+            <a:endParaRPr lang="en-US">
+              <a:ea typeface="Calibri"/>
+              <a:cs typeface="Calibri"/>
+            </a:endParaRPr>
           </a:p>
         </p:txBody>
       </p:sp>
     </p:spTree>
     <p:extLst>
       <p:ext uri="{BB962C8B-B14F-4D97-AF65-F5344CB8AC3E}">
-        <p14:creationId xmlns:p14="http://schemas.microsoft.com/office/powerpoint/2010/main" val="2369738800"/>
+        <p14:creationId xmlns:p14="http://schemas.microsoft.com/office/powerpoint/2010/main" val="4081741384"/>
       </p:ext>
     </p:extLst>
   </p:cSld>
@@ -11485,6 +11885,26 @@
 </file>
 
 <file path=customXml/item1.xml><?xml version="1.0" encoding="utf-8"?>
+<?mso-contentType ?>
+<FormTemplates xmlns="http://schemas.microsoft.com/sharepoint/v3/contenttype/forms">
+  <Display>DocumentLibraryForm</Display>
+  <Edit>DocumentLibraryForm</Edit>
+  <New>DocumentLibraryForm</New>
+</FormTemplates>
+</file>
+
+<file path=customXml/item2.xml><?xml version="1.0" encoding="utf-8"?>
+<p:properties xmlns:p="http://schemas.microsoft.com/office/2006/metadata/properties" xmlns:xsi="http://www.w3.org/2001/XMLSchema-instance" xmlns:pc="http://schemas.microsoft.com/office/infopath/2007/PartnerControls">
+  <documentManagement>
+    <lcf76f155ced4ddcb4097134ff3c332f xmlns="2cb0edea-a18e-4a3f-ae05-7740119d842b">
+      <Terms xmlns="http://schemas.microsoft.com/office/infopath/2007/PartnerControls"/>
+    </lcf76f155ced4ddcb4097134ff3c332f>
+    <TaxCatchAll xmlns="b14b2fa5-319f-4ece-99b9-f013105df540" xsi:nil="true"/>
+  </documentManagement>
+</p:properties>
+</file>
+
+<file path=customXml/item3.xml><?xml version="1.0" encoding="utf-8"?>
 <ct:contentTypeSchema xmlns:ct="http://schemas.microsoft.com/office/2006/metadata/contentType" xmlns:ma="http://schemas.microsoft.com/office/2006/metadata/properties/metaAttributes" ct:_="" ma:_="" ma:contentTypeName="Document" ma:contentTypeID="0x010100BE1E640C714C7E409BF3E7ADA81262C8" ma:contentTypeVersion="13" ma:contentTypeDescription="Create a new document." ma:contentTypeScope="" ma:versionID="3800f5a1cbaa027b407dce21277d6ea6">
   <xsd:schema xmlns:xsd="http://www.w3.org/2001/XMLSchema" xmlns:xs="http://www.w3.org/2001/XMLSchema" xmlns:p="http://schemas.microsoft.com/office/2006/metadata/properties" xmlns:ns2="2cb0edea-a18e-4a3f-ae05-7740119d842b" xmlns:ns3="b14b2fa5-319f-4ece-99b9-f013105df540" targetNamespace="http://schemas.microsoft.com/office/2006/metadata/properties" ma:root="true" ma:fieldsID="ea0fc5881f1a5b5ca6ae8f9c560ed4b7" ns2:_="" ns3:_="">
     <xsd:import namespace="2cb0edea-a18e-4a3f-ae05-7740119d842b"/>
@@ -11691,27 +12111,32 @@
 </ct:contentTypeSchema>
 </file>
 
-<file path=customXml/item2.xml><?xml version="1.0" encoding="utf-8"?>
-<?mso-contentType ?>
-<FormTemplates xmlns="http://schemas.microsoft.com/sharepoint/v3/contenttype/forms">
-  <Display>DocumentLibraryForm</Display>
-  <Edit>DocumentLibraryForm</Edit>
-  <New>DocumentLibraryForm</New>
-</FormTemplates>
+<file path=customXml/itemProps1.xml><?xml version="1.0" encoding="utf-8"?>
+<ds:datastoreItem xmlns:ds="http://schemas.openxmlformats.org/officeDocument/2006/customXml" ds:itemID="{171909B4-EC01-4B3B-84C5-71676D1C7516}">
+  <ds:schemaRefs>
+    <ds:schemaRef ds:uri="http://schemas.microsoft.com/sharepoint/v3/contenttype/forms"/>
+  </ds:schemaRefs>
+</ds:datastoreItem>
 </file>
 
-<file path=customXml/item3.xml><?xml version="1.0" encoding="utf-8"?>
-<p:properties xmlns:p="http://schemas.microsoft.com/office/2006/metadata/properties" xmlns:xsi="http://www.w3.org/2001/XMLSchema-instance" xmlns:pc="http://schemas.microsoft.com/office/infopath/2007/PartnerControls">
-  <documentManagement>
-    <lcf76f155ced4ddcb4097134ff3c332f xmlns="2cb0edea-a18e-4a3f-ae05-7740119d842b">
-      <Terms xmlns="http://schemas.microsoft.com/office/infopath/2007/PartnerControls"/>
-    </lcf76f155ced4ddcb4097134ff3c332f>
-    <TaxCatchAll xmlns="b14b2fa5-319f-4ece-99b9-f013105df540" xsi:nil="true"/>
-  </documentManagement>
-</p:properties>
+<file path=customXml/itemProps2.xml><?xml version="1.0" encoding="utf-8"?>
+<ds:datastoreItem xmlns:ds="http://schemas.openxmlformats.org/officeDocument/2006/customXml" ds:itemID="{0661F4C5-8AD5-41E9-A051-059681EE69BB}">
+  <ds:schemaRefs>
+    <ds:schemaRef ds:uri="2cb0edea-a18e-4a3f-ae05-7740119d842b"/>
+    <ds:schemaRef ds:uri="b14b2fa5-319f-4ece-99b9-f013105df540"/>
+    <ds:schemaRef ds:uri="http://purl.org/dc/dcmitype/"/>
+    <ds:schemaRef ds:uri="http://purl.org/dc/elements/1.1/"/>
+    <ds:schemaRef ds:uri="http://purl.org/dc/terms/"/>
+    <ds:schemaRef ds:uri="http://schemas.microsoft.com/office/2006/documentManagement/types"/>
+    <ds:schemaRef ds:uri="http://schemas.microsoft.com/office/2006/metadata/properties"/>
+    <ds:schemaRef ds:uri="http://schemas.microsoft.com/office/infopath/2007/PartnerControls"/>
+    <ds:schemaRef ds:uri="http://schemas.openxmlformats.org/package/2006/metadata/core-properties"/>
+    <ds:schemaRef ds:uri="http://www.w3.org/XML/1998/namespace"/>
+  </ds:schemaRefs>
+</ds:datastoreItem>
 </file>
 
-<file path=customXml/itemProps1.xml><?xml version="1.0" encoding="utf-8"?>
+<file path=customXml/itemProps3.xml><?xml version="1.0" encoding="utf-8"?>
 <ds:datastoreItem xmlns:ds="http://schemas.openxmlformats.org/officeDocument/2006/customXml" ds:itemID="{A3A92968-DBBC-4797-93ED-5DB6613C7A21}">
   <ds:schemaRefs>
     <ds:schemaRef ds:uri="2cb0edea-a18e-4a3f-ae05-7740119d842b"/>
@@ -11728,29 +12153,4 @@
     <ds:schemaRef ds:uri="http://www.w3.org/2001/XMLSchema"/>
   </ds:schemaRefs>
 </ds:datastoreItem>
-</file>
-
-<file path=customXml/itemProps2.xml><?xml version="1.0" encoding="utf-8"?>
-<ds:datastoreItem xmlns:ds="http://schemas.openxmlformats.org/officeDocument/2006/customXml" ds:itemID="{171909B4-EC01-4B3B-84C5-71676D1C7516}">
-  <ds:schemaRefs>
-    <ds:schemaRef ds:uri="http://schemas.microsoft.com/sharepoint/v3/contenttype/forms"/>
-  </ds:schemaRefs>
-</ds:datastoreItem>
-</file>
-
-<file path=customXml/itemProps3.xml><?xml version="1.0" encoding="utf-8"?>
-<ds:datastoreItem xmlns:ds="http://schemas.openxmlformats.org/officeDocument/2006/customXml" ds:itemID="{0661F4C5-8AD5-41E9-A051-059681EE69BB}">
-  <ds:schemaRefs>
-    <ds:schemaRef ds:uri="2cb0edea-a18e-4a3f-ae05-7740119d842b"/>
-    <ds:schemaRef ds:uri="b14b2fa5-319f-4ece-99b9-f013105df540"/>
-    <ds:schemaRef ds:uri="http://purl.org/dc/dcmitype/"/>
-    <ds:schemaRef ds:uri="http://purl.org/dc/elements/1.1/"/>
-    <ds:schemaRef ds:uri="http://purl.org/dc/terms/"/>
-    <ds:schemaRef ds:uri="http://schemas.microsoft.com/office/2006/documentManagement/types"/>
-    <ds:schemaRef ds:uri="http://schemas.microsoft.com/office/2006/metadata/properties"/>
-    <ds:schemaRef ds:uri="http://schemas.microsoft.com/office/infopath/2007/PartnerControls"/>
-    <ds:schemaRef ds:uri="http://schemas.openxmlformats.org/package/2006/metadata/core-properties"/>
-    <ds:schemaRef ds:uri="http://www.w3.org/XML/1998/namespace"/>
-  </ds:schemaRefs>
-</ds:datastoreItem>
 </file>
</xml_diff>